<commit_message>
Workshop-Folien: oberen Textabstand vereinheitlichen
Überblick- und Themen-Folien starteten Eyebrow/Titel auf abweichender Höhe
(0,55" bzw. 0,95") gegenüber Agenda/Übung/Recap (0,7"). Jetzt überall
einheitlich Eyebrow 0,7" / Titel 1,05" – gilt für alle vier Workshop-Decks
und die Vorlage.

Co-Authored-By: Claude Opus 4.8 <noreply@anthropic.com>
Claude-Session: https://claude.ai/code/session_01WnBp2TPEUEoiEVhGw13d39
</commit_message>
<xml_diff>
--- a/docs/workshop/7-stufen/WMDG-Workshop-7-Stufen.pptx
+++ b/docs/workshop/7-stufen/WMDG-Workshop-7-Stufen.pptx
@@ -2646,7 +2646,7 @@
         </p:blipFill>
         <p:spPr>
           <a:xfrm>
-            <a:off x="777240" y="777240"/>
+            <a:off x="777240" y="685800"/>
             <a:ext cx="1371600" cy="1371600"/>
           </a:xfrm>
           <a:prstGeom prst="rect">
@@ -2662,7 +2662,7 @@
         </p:nvSpPr>
         <p:spPr>
           <a:xfrm>
-            <a:off x="777240" y="777240"/>
+            <a:off x="777240" y="685800"/>
             <a:ext cx="1371600" cy="1371600"/>
           </a:xfrm>
           <a:prstGeom prst="rect">
@@ -2701,7 +2701,7 @@
         </p:nvSpPr>
         <p:spPr>
           <a:xfrm>
-            <a:off x="2423160" y="868680"/>
+            <a:off x="2423160" y="640080"/>
             <a:ext cx="7315200" cy="365760"/>
           </a:xfrm>
           <a:prstGeom prst="rect">
@@ -2740,7 +2740,7 @@
         </p:nvSpPr>
         <p:spPr>
           <a:xfrm>
-            <a:off x="2377440" y="1188720"/>
+            <a:off x="2377440" y="960120"/>
             <a:ext cx="8961120" cy="822960"/>
           </a:xfrm>
           <a:prstGeom prst="rect">
@@ -2779,7 +2779,7 @@
         </p:nvSpPr>
         <p:spPr>
           <a:xfrm>
-            <a:off x="2395728" y="2011680"/>
+            <a:off x="2395728" y="1828800"/>
             <a:ext cx="8961120" cy="457200"/>
           </a:xfrm>
           <a:prstGeom prst="rect">
@@ -3008,7 +3008,7 @@
         </p:blipFill>
         <p:spPr>
           <a:xfrm>
-            <a:off x="777240" y="777240"/>
+            <a:off x="777240" y="685800"/>
             <a:ext cx="1371600" cy="1371600"/>
           </a:xfrm>
           <a:prstGeom prst="rect">
@@ -3024,7 +3024,7 @@
         </p:nvSpPr>
         <p:spPr>
           <a:xfrm>
-            <a:off x="777240" y="777240"/>
+            <a:off x="777240" y="685800"/>
             <a:ext cx="1371600" cy="1371600"/>
           </a:xfrm>
           <a:prstGeom prst="rect">
@@ -3063,7 +3063,7 @@
         </p:nvSpPr>
         <p:spPr>
           <a:xfrm>
-            <a:off x="2423160" y="868680"/>
+            <a:off x="2423160" y="640080"/>
             <a:ext cx="7315200" cy="365760"/>
           </a:xfrm>
           <a:prstGeom prst="rect">
@@ -3102,7 +3102,7 @@
         </p:nvSpPr>
         <p:spPr>
           <a:xfrm>
-            <a:off x="2377440" y="1188720"/>
+            <a:off x="2377440" y="960120"/>
             <a:ext cx="8961120" cy="822960"/>
           </a:xfrm>
           <a:prstGeom prst="rect">
@@ -3141,7 +3141,7 @@
         </p:nvSpPr>
         <p:spPr>
           <a:xfrm>
-            <a:off x="2395728" y="2011680"/>
+            <a:off x="2395728" y="1828800"/>
             <a:ext cx="8961120" cy="457200"/>
           </a:xfrm>
           <a:prstGeom prst="rect">
@@ -3370,7 +3370,7 @@
         </p:blipFill>
         <p:spPr>
           <a:xfrm>
-            <a:off x="777240" y="777240"/>
+            <a:off x="777240" y="685800"/>
             <a:ext cx="1371600" cy="1371600"/>
           </a:xfrm>
           <a:prstGeom prst="rect">
@@ -3386,7 +3386,7 @@
         </p:nvSpPr>
         <p:spPr>
           <a:xfrm>
-            <a:off x="777240" y="777240"/>
+            <a:off x="777240" y="685800"/>
             <a:ext cx="1371600" cy="1371600"/>
           </a:xfrm>
           <a:prstGeom prst="rect">
@@ -3425,7 +3425,7 @@
         </p:nvSpPr>
         <p:spPr>
           <a:xfrm>
-            <a:off x="2423160" y="868680"/>
+            <a:off x="2423160" y="640080"/>
             <a:ext cx="7315200" cy="365760"/>
           </a:xfrm>
           <a:prstGeom prst="rect">
@@ -3464,7 +3464,7 @@
         </p:nvSpPr>
         <p:spPr>
           <a:xfrm>
-            <a:off x="2377440" y="1188720"/>
+            <a:off x="2377440" y="960120"/>
             <a:ext cx="8961120" cy="822960"/>
           </a:xfrm>
           <a:prstGeom prst="rect">
@@ -3503,7 +3503,7 @@
         </p:nvSpPr>
         <p:spPr>
           <a:xfrm>
-            <a:off x="2395728" y="2011680"/>
+            <a:off x="2395728" y="1828800"/>
             <a:ext cx="8961120" cy="457200"/>
           </a:xfrm>
           <a:prstGeom prst="rect">
@@ -3732,7 +3732,7 @@
         </p:blipFill>
         <p:spPr>
           <a:xfrm>
-            <a:off x="777240" y="777240"/>
+            <a:off x="777240" y="685800"/>
             <a:ext cx="1371600" cy="1371600"/>
           </a:xfrm>
           <a:prstGeom prst="rect">
@@ -3748,7 +3748,7 @@
         </p:nvSpPr>
         <p:spPr>
           <a:xfrm>
-            <a:off x="777240" y="777240"/>
+            <a:off x="777240" y="685800"/>
             <a:ext cx="1371600" cy="1371600"/>
           </a:xfrm>
           <a:prstGeom prst="rect">
@@ -3787,7 +3787,7 @@
         </p:nvSpPr>
         <p:spPr>
           <a:xfrm>
-            <a:off x="2423160" y="868680"/>
+            <a:off x="2423160" y="640080"/>
             <a:ext cx="7315200" cy="365760"/>
           </a:xfrm>
           <a:prstGeom prst="rect">
@@ -3826,7 +3826,7 @@
         </p:nvSpPr>
         <p:spPr>
           <a:xfrm>
-            <a:off x="2377440" y="1188720"/>
+            <a:off x="2377440" y="960120"/>
             <a:ext cx="8961120" cy="822960"/>
           </a:xfrm>
           <a:prstGeom prst="rect">
@@ -3865,7 +3865,7 @@
         </p:nvSpPr>
         <p:spPr>
           <a:xfrm>
-            <a:off x="2395728" y="2011680"/>
+            <a:off x="2395728" y="1828800"/>
             <a:ext cx="8961120" cy="457200"/>
           </a:xfrm>
           <a:prstGeom prst="rect">
@@ -4094,7 +4094,7 @@
         </p:blipFill>
         <p:spPr>
           <a:xfrm>
-            <a:off x="777240" y="777240"/>
+            <a:off x="777240" y="685800"/>
             <a:ext cx="1371600" cy="1371600"/>
           </a:xfrm>
           <a:prstGeom prst="rect">
@@ -4110,7 +4110,7 @@
         </p:nvSpPr>
         <p:spPr>
           <a:xfrm>
-            <a:off x="777240" y="777240"/>
+            <a:off x="777240" y="685800"/>
             <a:ext cx="1371600" cy="1371600"/>
           </a:xfrm>
           <a:prstGeom prst="rect">
@@ -4149,7 +4149,7 @@
         </p:nvSpPr>
         <p:spPr>
           <a:xfrm>
-            <a:off x="2423160" y="868680"/>
+            <a:off x="2423160" y="640080"/>
             <a:ext cx="7315200" cy="365760"/>
           </a:xfrm>
           <a:prstGeom prst="rect">
@@ -4188,7 +4188,7 @@
         </p:nvSpPr>
         <p:spPr>
           <a:xfrm>
-            <a:off x="2377440" y="1188720"/>
+            <a:off x="2377440" y="960120"/>
             <a:ext cx="8961120" cy="822960"/>
           </a:xfrm>
           <a:prstGeom prst="rect">
@@ -4227,7 +4227,7 @@
         </p:nvSpPr>
         <p:spPr>
           <a:xfrm>
-            <a:off x="2395728" y="2011680"/>
+            <a:off x="2395728" y="1828800"/>
             <a:ext cx="8961120" cy="457200"/>
           </a:xfrm>
           <a:prstGeom prst="rect">
@@ -8425,7 +8425,7 @@
         </p:nvSpPr>
         <p:spPr>
           <a:xfrm>
-            <a:off x="731520" y="502920"/>
+            <a:off x="731520" y="640080"/>
             <a:ext cx="7315200" cy="274320"/>
           </a:xfrm>
           <a:prstGeom prst="rect">
@@ -8464,7 +8464,7 @@
         </p:nvSpPr>
         <p:spPr>
           <a:xfrm>
-            <a:off x="731520" y="822960"/>
+            <a:off x="731520" y="960120"/>
             <a:ext cx="10698480" cy="731520"/>
           </a:xfrm>
           <a:prstGeom prst="rect">
@@ -9530,7 +9530,7 @@
         </p:blipFill>
         <p:spPr>
           <a:xfrm>
-            <a:off x="777240" y="777240"/>
+            <a:off x="777240" y="685800"/>
             <a:ext cx="1371600" cy="1371600"/>
           </a:xfrm>
           <a:prstGeom prst="rect">
@@ -9546,7 +9546,7 @@
         </p:nvSpPr>
         <p:spPr>
           <a:xfrm>
-            <a:off x="777240" y="777240"/>
+            <a:off x="777240" y="685800"/>
             <a:ext cx="1371600" cy="1371600"/>
           </a:xfrm>
           <a:prstGeom prst="rect">
@@ -9585,7 +9585,7 @@
         </p:nvSpPr>
         <p:spPr>
           <a:xfrm>
-            <a:off x="2423160" y="868680"/>
+            <a:off x="2423160" y="640080"/>
             <a:ext cx="7315200" cy="365760"/>
           </a:xfrm>
           <a:prstGeom prst="rect">
@@ -9624,7 +9624,7 @@
         </p:nvSpPr>
         <p:spPr>
           <a:xfrm>
-            <a:off x="2377440" y="1188720"/>
+            <a:off x="2377440" y="960120"/>
             <a:ext cx="8961120" cy="822960"/>
           </a:xfrm>
           <a:prstGeom prst="rect">
@@ -9663,7 +9663,7 @@
         </p:nvSpPr>
         <p:spPr>
           <a:xfrm>
-            <a:off x="2395728" y="2011680"/>
+            <a:off x="2395728" y="1828800"/>
             <a:ext cx="8961120" cy="457200"/>
           </a:xfrm>
           <a:prstGeom prst="rect">
@@ -9892,7 +9892,7 @@
         </p:blipFill>
         <p:spPr>
           <a:xfrm>
-            <a:off x="777240" y="777240"/>
+            <a:off x="777240" y="685800"/>
             <a:ext cx="1371600" cy="1371600"/>
           </a:xfrm>
           <a:prstGeom prst="rect">
@@ -9908,7 +9908,7 @@
         </p:nvSpPr>
         <p:spPr>
           <a:xfrm>
-            <a:off x="777240" y="777240"/>
+            <a:off x="777240" y="685800"/>
             <a:ext cx="1371600" cy="1371600"/>
           </a:xfrm>
           <a:prstGeom prst="rect">
@@ -9947,7 +9947,7 @@
         </p:nvSpPr>
         <p:spPr>
           <a:xfrm>
-            <a:off x="2423160" y="868680"/>
+            <a:off x="2423160" y="640080"/>
             <a:ext cx="7315200" cy="365760"/>
           </a:xfrm>
           <a:prstGeom prst="rect">
@@ -9986,7 +9986,7 @@
         </p:nvSpPr>
         <p:spPr>
           <a:xfrm>
-            <a:off x="2377440" y="1188720"/>
+            <a:off x="2377440" y="960120"/>
             <a:ext cx="8961120" cy="822960"/>
           </a:xfrm>
           <a:prstGeom prst="rect">
@@ -10025,7 +10025,7 @@
         </p:nvSpPr>
         <p:spPr>
           <a:xfrm>
-            <a:off x="2395728" y="2011680"/>
+            <a:off x="2395728" y="1828800"/>
             <a:ext cx="8961120" cy="457200"/>
           </a:xfrm>
           <a:prstGeom prst="rect">

</xml_diff>